<commit_message>
Phase 7: final re-run, Next.js demo app with live zone map
- Re-ran all four notebooks top to bottom; refreshed reports, model and slides
- New demo: FastAPI service (app/app.py) serving a forecast API and a Next.js
  interface (app/web) with a live zone map, hour slider, forecast curve with
  80% range and event windows, driver plan by shift, zone leaderboard and
  hourly table with CSV export
- Usual-day comparison now uses the same weekday from the last 8 weeks
- Streamlit version kept as a fallback (app/streamlit_app.py)
- README demo section, requirements pins and slide 5 updated
</commit_message>
<xml_diff>
--- a/presentation/team_teamdev_slides.pptx
+++ b/presentation/team_teamdev_slides.pptx
@@ -111,27 +111,27 @@
   <p:extLst>
     <p:ext uri="{521415D9-36F7-43E2-AB2F-B90AF26B5E84}">
       <p14:sectionLst xmlns:p14="http://schemas.microsoft.com/office/powerpoint/2010/main">
-        <p14:section name="Overview" id="{c1b73e2f-9f53-d473-13f5-202691991044}">
+        <p14:section name="Overview" id="{84e88d6e-e839-3e33-c548-c3874d35c5c8}">
           <p14:sldIdLst>
             <p14:sldId id="256"/>
           </p14:sldIdLst>
         </p14:section>
-        <p14:section name="Data" id="{8ca25ee2-9f21-85a9-0f83-f8fb92974d14}">
+        <p14:section name="Data" id="{525aedb6-50c6-17f5-c528-f60f17f72d92}">
           <p14:sldIdLst>
             <p14:sldId id="257"/>
           </p14:sldIdLst>
         </p14:section>
-        <p14:section name="Findings" id="{c51eeaea-0a29-a7ea-644e-d25c03f01cde}">
+        <p14:section name="Findings" id="{804405b9-8d47-576d-9b62-febd523a64ab}">
           <p14:sldIdLst>
             <p14:sldId id="258"/>
           </p14:sldIdLst>
         </p14:section>
-        <p14:section name="Model" id="{6e805ac4-bb99-77dc-042f-51c48d427cb5}">
+        <p14:section name="Model" id="{f483febc-9c5b-1234-08a6-6fc8ac2537f4}">
           <p14:sldIdLst>
             <p14:sldId id="259"/>
           </p14:sldIdLst>
         </p14:section>
-        <p14:section name="Close" id="{7914c9d7-f3ac-a6b9-28d2-921701bccf92}">
+        <p14:section name="Close" id="{025290b3-488e-8aa2-126a-78d53ca2584b}">
           <p14:sldIdLst>
             <p14:sldId id="260"/>
           </p14:sldIdLst>
@@ -1655,7 +1655,43 @@
       </p:sp>
       <p:sp>
         <p:nvSpPr>
-          <p:cNvPr id="4" name="rule"/>
+          <p:cNvPr id="4" name="Text 2"/>
+          <p:cNvSpPr txBox="1"/>
+          <p:nvPr/>
+        </p:nvSpPr>
+        <p:spPr>
+          <a:xfrm>
+            <a:off x="822960" y="4343400"/>
+            <a:ext cx="10515600" cy="365760"/>
+          </a:xfrm>
+          <a:prstGeom prst="rect">
+            <a:avLst/>
+          </a:prstGeom>
+          <a:noFill/>
+          <a:ln/>
+        </p:spPr>
+        <p:txBody>
+          <a:bodyPr wrap="square" lIns="0" tIns="0" rIns="0" bIns="0" rtlCol="0" anchor="ctr"/>
+          <a:lstStyle/>
+          <a:p>
+            <a:pPr indent="0" marL="0">
+              <a:buNone/>
+            </a:pPr>
+            <a:r>
+              <a:rPr lang="en-US" sz="1300" dirty="0">
+                <a:solidFill>
+                  <a:srgbClr val="F7B699"/>
+                </a:solidFill>
+              </a:rPr>
+              <a:t>Abraham Gebeyehu  ·  Bethelhem Legesse  ·  Eden Kibret  ·  Eleni Andualem  ·  Feven Abebe  ·  Surafel Solomon</a:t>
+            </a:r>
+            <a:endParaRPr lang="en-US" sz="1300" dirty="0"/>
+          </a:p>
+        </p:txBody>
+      </p:sp>
+      <p:sp>
+        <p:nvSpPr>
+          <p:cNvPr id="5" name="rule"/>
           <p:cNvSpPr/>
           <p:nvPr/>
         </p:nvSpPr>
@@ -1680,7 +1716,7 @@
       </p:sp>
       <p:sp>
         <p:nvSpPr>
-          <p:cNvPr id="5" name="Text 3"/>
+          <p:cNvPr id="6" name="Text 4"/>
           <p:cNvSpPr txBox="1"/>
           <p:nvPr/>
         </p:nvSpPr>
@@ -4359,7 +4395,7 @@
                   <a:schemeClr val="tx1"/>
                 </a:solidFill>
               </a:rPr>
-              <a:t>Runs locally: streamlit run app/app.py</a:t>
+              <a:t>Runs locally: python app/app.py → localhost:8000</a:t>
             </a:r>
             <a:endParaRPr lang="en-US" sz="1250" dirty="0"/>
           </a:p>
@@ -4380,7 +4416,7 @@
                   <a:schemeClr val="tx1"/>
                 </a:solidFill>
               </a:rPr>
-              <a:t>Pick a zone and a day; the app looks up weather and events itself</a:t>
+              <a:t>Live city map of all 12 zones; pick a zone and a day and it looks up weather and events itself</a:t>
             </a:r>
             <a:endParaRPr lang="en-US" sz="1250" dirty="0"/>
           </a:p>

</xml_diff>